<commit_message>
Added favicon, more text
</commit_message>
<xml_diff>
--- a/images/Presentation1.pptx
+++ b/images/Presentation1.pptx
@@ -243,7 +243,7 @@
           <a:p>
             <a:fld id="{B09D61B1-95AD-1C46-9339-F35331A5CBA5}" type="datetimeFigureOut">
               <a:rPr lang="en-US" smtClean="0"/>
-              <a:t>12/26/16</a:t>
+              <a:t>12/29/16</a:t>
             </a:fld>
             <a:endParaRPr lang="en-US"/>
           </a:p>
@@ -413,7 +413,7 @@
           <a:p>
             <a:fld id="{B09D61B1-95AD-1C46-9339-F35331A5CBA5}" type="datetimeFigureOut">
               <a:rPr lang="en-US" smtClean="0"/>
-              <a:t>12/26/16</a:t>
+              <a:t>12/29/16</a:t>
             </a:fld>
             <a:endParaRPr lang="en-US"/>
           </a:p>
@@ -593,7 +593,7 @@
           <a:p>
             <a:fld id="{B09D61B1-95AD-1C46-9339-F35331A5CBA5}" type="datetimeFigureOut">
               <a:rPr lang="en-US" smtClean="0"/>
-              <a:t>12/26/16</a:t>
+              <a:t>12/29/16</a:t>
             </a:fld>
             <a:endParaRPr lang="en-US"/>
           </a:p>
@@ -763,7 +763,7 @@
           <a:p>
             <a:fld id="{B09D61B1-95AD-1C46-9339-F35331A5CBA5}" type="datetimeFigureOut">
               <a:rPr lang="en-US" smtClean="0"/>
-              <a:t>12/26/16</a:t>
+              <a:t>12/29/16</a:t>
             </a:fld>
             <a:endParaRPr lang="en-US"/>
           </a:p>
@@ -1009,7 +1009,7 @@
           <a:p>
             <a:fld id="{B09D61B1-95AD-1C46-9339-F35331A5CBA5}" type="datetimeFigureOut">
               <a:rPr lang="en-US" smtClean="0"/>
-              <a:t>12/26/16</a:t>
+              <a:t>12/29/16</a:t>
             </a:fld>
             <a:endParaRPr lang="en-US"/>
           </a:p>
@@ -1241,7 +1241,7 @@
           <a:p>
             <a:fld id="{B09D61B1-95AD-1C46-9339-F35331A5CBA5}" type="datetimeFigureOut">
               <a:rPr lang="en-US" smtClean="0"/>
-              <a:t>12/26/16</a:t>
+              <a:t>12/29/16</a:t>
             </a:fld>
             <a:endParaRPr lang="en-US"/>
           </a:p>
@@ -1608,7 +1608,7 @@
           <a:p>
             <a:fld id="{B09D61B1-95AD-1C46-9339-F35331A5CBA5}" type="datetimeFigureOut">
               <a:rPr lang="en-US" smtClean="0"/>
-              <a:t>12/26/16</a:t>
+              <a:t>12/29/16</a:t>
             </a:fld>
             <a:endParaRPr lang="en-US"/>
           </a:p>
@@ -1726,7 +1726,7 @@
           <a:p>
             <a:fld id="{B09D61B1-95AD-1C46-9339-F35331A5CBA5}" type="datetimeFigureOut">
               <a:rPr lang="en-US" smtClean="0"/>
-              <a:t>12/26/16</a:t>
+              <a:t>12/29/16</a:t>
             </a:fld>
             <a:endParaRPr lang="en-US"/>
           </a:p>
@@ -1821,7 +1821,7 @@
           <a:p>
             <a:fld id="{B09D61B1-95AD-1C46-9339-F35331A5CBA5}" type="datetimeFigureOut">
               <a:rPr lang="en-US" smtClean="0"/>
-              <a:t>12/26/16</a:t>
+              <a:t>12/29/16</a:t>
             </a:fld>
             <a:endParaRPr lang="en-US"/>
           </a:p>
@@ -2098,7 +2098,7 @@
           <a:p>
             <a:fld id="{B09D61B1-95AD-1C46-9339-F35331A5CBA5}" type="datetimeFigureOut">
               <a:rPr lang="en-US" smtClean="0"/>
-              <a:t>12/26/16</a:t>
+              <a:t>12/29/16</a:t>
             </a:fld>
             <a:endParaRPr lang="en-US"/>
           </a:p>
@@ -2351,7 +2351,7 @@
           <a:p>
             <a:fld id="{B09D61B1-95AD-1C46-9339-F35331A5CBA5}" type="datetimeFigureOut">
               <a:rPr lang="en-US" smtClean="0"/>
-              <a:t>12/26/16</a:t>
+              <a:t>12/29/16</a:t>
             </a:fld>
             <a:endParaRPr lang="en-US"/>
           </a:p>
@@ -2564,7 +2564,7 @@
           <a:p>
             <a:fld id="{B09D61B1-95AD-1C46-9339-F35331A5CBA5}" type="datetimeFigureOut">
               <a:rPr lang="en-US" smtClean="0"/>
-              <a:t>12/26/16</a:t>
+              <a:t>12/29/16</a:t>
             </a:fld>
             <a:endParaRPr lang="en-US"/>
           </a:p>
@@ -2977,16 +2977,251 @@
           <a:chExt cx="0" cy="0"/>
         </a:xfrm>
       </p:grpSpPr>
+      <p:grpSp>
+        <p:nvGrpSpPr>
+          <p:cNvPr id="8" name="Group 7"/>
+          <p:cNvGrpSpPr/>
+          <p:nvPr/>
+        </p:nvGrpSpPr>
+        <p:grpSpPr>
+          <a:xfrm>
+            <a:off x="-3530877" y="-1010810"/>
+            <a:ext cx="9363840" cy="9450841"/>
+            <a:chOff x="-265163" y="17890"/>
+            <a:chExt cx="9363840" cy="9450841"/>
+          </a:xfrm>
+        </p:grpSpPr>
+        <p:pic>
+          <p:nvPicPr>
+            <p:cNvPr id="21" name="Picture 20"/>
+            <p:cNvPicPr>
+              <a:picLocks noChangeAspect="1"/>
+            </p:cNvPicPr>
+            <p:nvPr/>
+          </p:nvPicPr>
+          <p:blipFill>
+            <a:blip r:embed="rId2">
+              <a:extLst>
+                <a:ext uri="{28A0092B-C50C-407E-A947-70E740481C1C}">
+                  <a14:useLocalDpi xmlns:a14="http://schemas.microsoft.com/office/drawing/2010/main" val="0"/>
+                </a:ext>
+              </a:extLst>
+            </a:blip>
+            <a:stretch>
+              <a:fillRect/>
+            </a:stretch>
+          </p:blipFill>
+          <p:spPr>
+            <a:xfrm rot="2286516">
+              <a:off x="1848298" y="2522374"/>
+              <a:ext cx="5428665" cy="4569126"/>
+            </a:xfrm>
+            <a:prstGeom prst="rect">
+              <a:avLst/>
+            </a:prstGeom>
+            <a:blipFill>
+              <a:blip r:embed="rId3"/>
+              <a:stretch>
+                <a:fillRect/>
+              </a:stretch>
+            </a:blipFill>
+          </p:spPr>
+        </p:pic>
+        <p:sp>
+          <p:nvSpPr>
+            <p:cNvPr id="2" name="Rectangle 1"/>
+            <p:cNvSpPr/>
+            <p:nvPr/>
+          </p:nvSpPr>
+          <p:spPr>
+            <a:xfrm rot="2337567">
+              <a:off x="2872391" y="2381987"/>
+              <a:ext cx="6226286" cy="628858"/>
+            </a:xfrm>
+            <a:prstGeom prst="rect">
+              <a:avLst/>
+            </a:prstGeom>
+            <a:solidFill>
+              <a:schemeClr val="tx1"/>
+            </a:solidFill>
+            <a:ln>
+              <a:noFill/>
+            </a:ln>
+          </p:spPr>
+          <p:style>
+            <a:lnRef idx="2">
+              <a:schemeClr val="accent1">
+                <a:shade val="50000"/>
+              </a:schemeClr>
+            </a:lnRef>
+            <a:fillRef idx="1">
+              <a:schemeClr val="accent1"/>
+            </a:fillRef>
+            <a:effectRef idx="0">
+              <a:schemeClr val="accent1"/>
+            </a:effectRef>
+            <a:fontRef idx="minor">
+              <a:schemeClr val="lt1"/>
+            </a:fontRef>
+          </p:style>
+          <p:txBody>
+            <a:bodyPr rtlCol="0" anchor="ctr"/>
+            <a:lstStyle/>
+            <a:p>
+              <a:pPr algn="ctr"/>
+              <a:endParaRPr lang="en-US"/>
+            </a:p>
+          </p:txBody>
+        </p:sp>
+        <p:sp>
+          <p:nvSpPr>
+            <p:cNvPr id="4" name="Rectangle 3"/>
+            <p:cNvSpPr/>
+            <p:nvPr/>
+          </p:nvSpPr>
+          <p:spPr>
+            <a:xfrm rot="2337567">
+              <a:off x="-265163" y="6232179"/>
+              <a:ext cx="6226286" cy="628858"/>
+            </a:xfrm>
+            <a:prstGeom prst="rect">
+              <a:avLst/>
+            </a:prstGeom>
+            <a:solidFill>
+              <a:schemeClr val="tx1"/>
+            </a:solidFill>
+            <a:ln>
+              <a:noFill/>
+            </a:ln>
+          </p:spPr>
+          <p:style>
+            <a:lnRef idx="2">
+              <a:schemeClr val="accent1">
+                <a:shade val="50000"/>
+              </a:schemeClr>
+            </a:lnRef>
+            <a:fillRef idx="1">
+              <a:schemeClr val="accent1"/>
+            </a:fillRef>
+            <a:effectRef idx="0">
+              <a:schemeClr val="accent1"/>
+            </a:effectRef>
+            <a:fontRef idx="minor">
+              <a:schemeClr val="lt1"/>
+            </a:fontRef>
+          </p:style>
+          <p:txBody>
+            <a:bodyPr rtlCol="0" anchor="ctr"/>
+            <a:lstStyle/>
+            <a:p>
+              <a:pPr algn="ctr"/>
+              <a:endParaRPr lang="en-US"/>
+            </a:p>
+          </p:txBody>
+        </p:sp>
+        <p:sp>
+          <p:nvSpPr>
+            <p:cNvPr id="5" name="Rectangle 4"/>
+            <p:cNvSpPr/>
+            <p:nvPr/>
+          </p:nvSpPr>
+          <p:spPr>
+            <a:xfrm rot="7612580">
+              <a:off x="3477277" y="6041159"/>
+              <a:ext cx="6226286" cy="628858"/>
+            </a:xfrm>
+            <a:prstGeom prst="rect">
+              <a:avLst/>
+            </a:prstGeom>
+            <a:solidFill>
+              <a:schemeClr val="tx1"/>
+            </a:solidFill>
+            <a:ln>
+              <a:noFill/>
+            </a:ln>
+          </p:spPr>
+          <p:style>
+            <a:lnRef idx="2">
+              <a:schemeClr val="accent1">
+                <a:shade val="50000"/>
+              </a:schemeClr>
+            </a:lnRef>
+            <a:fillRef idx="1">
+              <a:schemeClr val="accent1"/>
+            </a:fillRef>
+            <a:effectRef idx="0">
+              <a:schemeClr val="accent1"/>
+            </a:effectRef>
+            <a:fontRef idx="minor">
+              <a:schemeClr val="lt1"/>
+            </a:fontRef>
+          </p:style>
+          <p:txBody>
+            <a:bodyPr rtlCol="0" anchor="ctr"/>
+            <a:lstStyle/>
+            <a:p>
+              <a:pPr algn="ctr"/>
+              <a:endParaRPr lang="en-US"/>
+            </a:p>
+          </p:txBody>
+        </p:sp>
+        <p:sp>
+          <p:nvSpPr>
+            <p:cNvPr id="7" name="Rectangle 6"/>
+            <p:cNvSpPr/>
+            <p:nvPr/>
+          </p:nvSpPr>
+          <p:spPr>
+            <a:xfrm rot="7612580">
+              <a:off x="-547150" y="2816604"/>
+              <a:ext cx="6226286" cy="628858"/>
+            </a:xfrm>
+            <a:prstGeom prst="rect">
+              <a:avLst/>
+            </a:prstGeom>
+            <a:solidFill>
+              <a:schemeClr val="tx1"/>
+            </a:solidFill>
+            <a:ln>
+              <a:noFill/>
+            </a:ln>
+          </p:spPr>
+          <p:style>
+            <a:lnRef idx="2">
+              <a:schemeClr val="accent1">
+                <a:shade val="50000"/>
+              </a:schemeClr>
+            </a:lnRef>
+            <a:fillRef idx="1">
+              <a:schemeClr val="accent1"/>
+            </a:fillRef>
+            <a:effectRef idx="0">
+              <a:schemeClr val="accent1"/>
+            </a:effectRef>
+            <a:fontRef idx="minor">
+              <a:schemeClr val="lt1"/>
+            </a:fontRef>
+          </p:style>
+          <p:txBody>
+            <a:bodyPr rtlCol="0" anchor="ctr"/>
+            <a:lstStyle/>
+            <a:p>
+              <a:pPr algn="ctr"/>
+              <a:endParaRPr lang="en-US"/>
+            </a:p>
+          </p:txBody>
+        </p:sp>
+      </p:grpSp>
       <p:pic>
         <p:nvPicPr>
-          <p:cNvPr id="21" name="Picture 20"/>
+          <p:cNvPr id="6" name="Picture 5"/>
           <p:cNvPicPr>
             <a:picLocks noChangeAspect="1"/>
           </p:cNvPicPr>
           <p:nvPr/>
         </p:nvPicPr>
         <p:blipFill>
-          <a:blip r:embed="rId2">
+          <a:blip r:embed="rId3">
             <a:extLst>
               <a:ext uri="{28A0092B-C50C-407E-A947-70E740481C1C}">
                 <a14:useLocalDpi xmlns:a14="http://schemas.microsoft.com/office/drawing/2010/main" val="0"/>
@@ -2998,205 +3233,45 @@
           </a:stretch>
         </p:blipFill>
         <p:spPr>
-          <a:xfrm rot="2286516">
-            <a:off x="1863874" y="2437534"/>
-            <a:ext cx="5428665" cy="4569126"/>
+          <a:xfrm>
+            <a:off x="3190083" y="1342191"/>
+            <a:ext cx="7241157" cy="5523816"/>
           </a:xfrm>
           <a:prstGeom prst="rect">
             <a:avLst/>
           </a:prstGeom>
-          <a:blipFill>
-            <a:blip r:embed="rId3"/>
-            <a:stretch>
-              <a:fillRect/>
-            </a:stretch>
-          </a:blipFill>
         </p:spPr>
       </p:pic>
-      <p:sp>
-        <p:nvSpPr>
-          <p:cNvPr id="2" name="Rectangle 1"/>
-          <p:cNvSpPr/>
+      <p:pic>
+        <p:nvPicPr>
+          <p:cNvPr id="3" name="Picture 2"/>
+          <p:cNvPicPr>
+            <a:picLocks noChangeAspect="1"/>
+          </p:cNvPicPr>
           <p:nvPr/>
-        </p:nvSpPr>
+        </p:nvPicPr>
+        <p:blipFill>
+          <a:blip r:embed="rId4">
+            <a:extLst>
+              <a:ext uri="{28A0092B-C50C-407E-A947-70E740481C1C}">
+                <a14:useLocalDpi xmlns:a14="http://schemas.microsoft.com/office/drawing/2010/main" val="0"/>
+              </a:ext>
+            </a:extLst>
+          </a:blip>
+          <a:stretch>
+            <a:fillRect/>
+          </a:stretch>
+        </p:blipFill>
         <p:spPr>
-          <a:xfrm rot="2337567">
-            <a:off x="2872391" y="2381987"/>
-            <a:ext cx="6226286" cy="628858"/>
+          <a:xfrm>
+            <a:off x="6989049" y="1564099"/>
+            <a:ext cx="2540000" cy="2540000"/>
           </a:xfrm>
           <a:prstGeom prst="rect">
             <a:avLst/>
           </a:prstGeom>
-          <a:solidFill>
-            <a:schemeClr val="tx1"/>
-          </a:solidFill>
-          <a:ln>
-            <a:noFill/>
-          </a:ln>
         </p:spPr>
-        <p:style>
-          <a:lnRef idx="2">
-            <a:schemeClr val="accent1">
-              <a:shade val="50000"/>
-            </a:schemeClr>
-          </a:lnRef>
-          <a:fillRef idx="1">
-            <a:schemeClr val="accent1"/>
-          </a:fillRef>
-          <a:effectRef idx="0">
-            <a:schemeClr val="accent1"/>
-          </a:effectRef>
-          <a:fontRef idx="minor">
-            <a:schemeClr val="lt1"/>
-          </a:fontRef>
-        </p:style>
-        <p:txBody>
-          <a:bodyPr rtlCol="0" anchor="ctr"/>
-          <a:lstStyle/>
-          <a:p>
-            <a:pPr algn="ctr"/>
-            <a:endParaRPr lang="en-US"/>
-          </a:p>
-        </p:txBody>
-      </p:sp>
-      <p:sp>
-        <p:nvSpPr>
-          <p:cNvPr id="4" name="Rectangle 3"/>
-          <p:cNvSpPr/>
-          <p:nvPr/>
-        </p:nvSpPr>
-        <p:spPr>
-          <a:xfrm rot="2337567">
-            <a:off x="-265163" y="6232179"/>
-            <a:ext cx="6226286" cy="628858"/>
-          </a:xfrm>
-          <a:prstGeom prst="rect">
-            <a:avLst/>
-          </a:prstGeom>
-          <a:solidFill>
-            <a:schemeClr val="tx1"/>
-          </a:solidFill>
-          <a:ln>
-            <a:noFill/>
-          </a:ln>
-        </p:spPr>
-        <p:style>
-          <a:lnRef idx="2">
-            <a:schemeClr val="accent1">
-              <a:shade val="50000"/>
-            </a:schemeClr>
-          </a:lnRef>
-          <a:fillRef idx="1">
-            <a:schemeClr val="accent1"/>
-          </a:fillRef>
-          <a:effectRef idx="0">
-            <a:schemeClr val="accent1"/>
-          </a:effectRef>
-          <a:fontRef idx="minor">
-            <a:schemeClr val="lt1"/>
-          </a:fontRef>
-        </p:style>
-        <p:txBody>
-          <a:bodyPr rtlCol="0" anchor="ctr"/>
-          <a:lstStyle/>
-          <a:p>
-            <a:pPr algn="ctr"/>
-            <a:endParaRPr lang="en-US"/>
-          </a:p>
-        </p:txBody>
-      </p:sp>
-      <p:sp>
-        <p:nvSpPr>
-          <p:cNvPr id="5" name="Rectangle 4"/>
-          <p:cNvSpPr/>
-          <p:nvPr/>
-        </p:nvSpPr>
-        <p:spPr>
-          <a:xfrm rot="7612580">
-            <a:off x="3477277" y="6041159"/>
-            <a:ext cx="6226286" cy="628858"/>
-          </a:xfrm>
-          <a:prstGeom prst="rect">
-            <a:avLst/>
-          </a:prstGeom>
-          <a:solidFill>
-            <a:schemeClr val="tx1"/>
-          </a:solidFill>
-          <a:ln>
-            <a:noFill/>
-          </a:ln>
-        </p:spPr>
-        <p:style>
-          <a:lnRef idx="2">
-            <a:schemeClr val="accent1">
-              <a:shade val="50000"/>
-            </a:schemeClr>
-          </a:lnRef>
-          <a:fillRef idx="1">
-            <a:schemeClr val="accent1"/>
-          </a:fillRef>
-          <a:effectRef idx="0">
-            <a:schemeClr val="accent1"/>
-          </a:effectRef>
-          <a:fontRef idx="minor">
-            <a:schemeClr val="lt1"/>
-          </a:fontRef>
-        </p:style>
-        <p:txBody>
-          <a:bodyPr rtlCol="0" anchor="ctr"/>
-          <a:lstStyle/>
-          <a:p>
-            <a:pPr algn="ctr"/>
-            <a:endParaRPr lang="en-US"/>
-          </a:p>
-        </p:txBody>
-      </p:sp>
-      <p:sp>
-        <p:nvSpPr>
-          <p:cNvPr id="7" name="Rectangle 6"/>
-          <p:cNvSpPr/>
-          <p:nvPr/>
-        </p:nvSpPr>
-        <p:spPr>
-          <a:xfrm rot="7612580">
-            <a:off x="-547150" y="2816604"/>
-            <a:ext cx="6226286" cy="628858"/>
-          </a:xfrm>
-          <a:prstGeom prst="rect">
-            <a:avLst/>
-          </a:prstGeom>
-          <a:solidFill>
-            <a:schemeClr val="tx1"/>
-          </a:solidFill>
-          <a:ln>
-            <a:noFill/>
-          </a:ln>
-        </p:spPr>
-        <p:style>
-          <a:lnRef idx="2">
-            <a:schemeClr val="accent1">
-              <a:shade val="50000"/>
-            </a:schemeClr>
-          </a:lnRef>
-          <a:fillRef idx="1">
-            <a:schemeClr val="accent1"/>
-          </a:fillRef>
-          <a:effectRef idx="0">
-            <a:schemeClr val="accent1"/>
-          </a:effectRef>
-          <a:fontRef idx="minor">
-            <a:schemeClr val="lt1"/>
-          </a:fontRef>
-        </p:style>
-        <p:txBody>
-          <a:bodyPr rtlCol="0" anchor="ctr"/>
-          <a:lstStyle/>
-          <a:p>
-            <a:pPr algn="ctr"/>
-            <a:endParaRPr lang="en-US"/>
-          </a:p>
-        </p:txBody>
-      </p:sp>
+      </p:pic>
     </p:spTree>
     <p:extLst>
       <p:ext uri="{BB962C8B-B14F-4D97-AF65-F5344CB8AC3E}">

</xml_diff>

<commit_message>
Not sure what changed here
</commit_message>
<xml_diff>
--- a/images/Presentation1.pptx
+++ b/images/Presentation1.pptx
@@ -3272,6 +3272,36 @@
           </a:prstGeom>
         </p:spPr>
       </p:pic>
+      <p:pic>
+        <p:nvPicPr>
+          <p:cNvPr id="10" name="Picture 9"/>
+          <p:cNvPicPr>
+            <a:picLocks noChangeAspect="1"/>
+          </p:cNvPicPr>
+          <p:nvPr/>
+        </p:nvPicPr>
+        <p:blipFill>
+          <a:blip r:embed="rId5">
+            <a:extLst>
+              <a:ext uri="{28A0092B-C50C-407E-A947-70E740481C1C}">
+                <a14:useLocalDpi xmlns:a14="http://schemas.microsoft.com/office/drawing/2010/main" val="0"/>
+              </a:ext>
+            </a:extLst>
+          </a:blip>
+          <a:stretch>
+            <a:fillRect/>
+          </a:stretch>
+        </p:blipFill>
+        <p:spPr>
+          <a:xfrm>
+            <a:off x="6989049" y="1564099"/>
+            <a:ext cx="2540000" cy="2540000"/>
+          </a:xfrm>
+          <a:prstGeom prst="rect">
+            <a:avLst/>
+          </a:prstGeom>
+        </p:spPr>
+      </p:pic>
     </p:spTree>
     <p:extLst>
       <p:ext uri="{BB962C8B-B14F-4D97-AF65-F5344CB8AC3E}">

</xml_diff>